<commit_message>
Focus slides on framework differences and update presentation script
</commit_message>
<xml_diff>
--- a/presentacion/Comparativa_Frontend_InventoryPro.pptx
+++ b/presentacion/Comparativa_Frontend_InventoryPro.pptx
@@ -381,7 +381,7 @@
             <a:pPr indent="0" algn="r">
               <a:buNone/>
             </a:pPr>
-            <a:fld id="{2083D8AD-562D-466B-837F-64FB9CDECF68}" type="slidenum">
+            <a:fld id="{FF3C0BB4-E29D-425D-9749-A776303F1553}" type="slidenum">
               <a:rPr lang="en-US" sz="1400" b="0" u="none" strike="noStrike">
                 <a:solidFill>
                   <a:srgbClr val="000000"/>
@@ -428,7 +428,7 @@
       </p:grpSpPr>
       <p:sp>
         <p:nvSpPr>
-          <p:cNvPr id="199" name="PlaceHolder 1"/>
+          <p:cNvPr id="195" name="PlaceHolder 1"/>
           <p:cNvSpPr>
             <a:spLocks noGrp="1"/>
           </p:cNvSpPr>
@@ -451,7 +451,7 @@
       </p:sp>
       <p:sp>
         <p:nvSpPr>
-          <p:cNvPr id="200" name="PlaceHolder 2"/>
+          <p:cNvPr id="196" name="PlaceHolder 2"/>
           <p:cNvSpPr>
             <a:spLocks noGrp="1"/>
           </p:cNvSpPr>
@@ -497,7 +497,7 @@
                 <a:latin typeface="Arial"/>
                 <a:ea typeface="Arial"/>
               </a:rPr>
-              <a:t>Presento una comparación práctica de cuatro tecnologías frontend. La idea es mantener la misma aplicación y observar cómo cambia su implementación y la respuesta de la interfaz. React se incluye como biblioteca de UI, junto con los otros frameworks. Duración sugerida: 20 segundos.</a:t>
+              <a:t>Hoy compararé React, Vue, Angular y Svelte. Las cuatro tecnologías permiten construir interfaces con componentes, pero difieren en su alcance, su sintaxis, su reactividad y las herramientas que ofrecen. Primero explicaré esas diferencias y al final mostraré una misma aplicación implementada con cada una. [20 segundos]</a:t>
             </a:r>
             <a:endParaRPr lang="en-US" sz="1100" b="0" u="none" strike="noStrike">
               <a:solidFill>
@@ -534,7 +534,7 @@
       </p:grpSpPr>
       <p:sp>
         <p:nvSpPr>
-          <p:cNvPr id="201" name="PlaceHolder 1"/>
+          <p:cNvPr id="197" name="PlaceHolder 1"/>
           <p:cNvSpPr>
             <a:spLocks noGrp="1"/>
           </p:cNvSpPr>
@@ -557,7 +557,7 @@
       </p:sp>
       <p:sp>
         <p:nvSpPr>
-          <p:cNvPr id="202" name="PlaceHolder 2"/>
+          <p:cNvPr id="198" name="PlaceHolder 2"/>
           <p:cNvSpPr>
             <a:spLocks noGrp="1"/>
           </p:cNvSpPr>
@@ -603,7 +603,7 @@
                 <a:latin typeface="Arial"/>
                 <a:ea typeface="Arial"/>
               </a:rPr>
-              <a:t>InventoryPro es una aplicación de inventario con dashboard, tabla y formulario. Las cuatro versiones ofrecen las mismas operaciones. Los datos se generan localmente y con semilla fija; no interviene una API ni una base de datos. La imagen corresponde a la versión React. Duración sugerida: 25 segundos.</a:t>
+              <a:t>La comparación no consiste solamente en medir cuál carga más rápido. También importa cómo se escribe el código, cómo se organiza el estado, qué herramientas trae la tecnología y cuánto debe decidir el equipo. Usaré estos criterios para explicar las diferencias. React es una biblioteca de interfaz; Vue, Angular y Svelte se presentan como frameworks, aunque tienen alcances distintos. [25 segundos]</a:t>
             </a:r>
             <a:endParaRPr lang="en-US" sz="1100" b="0" u="none" strike="noStrike">
               <a:solidFill>
@@ -640,7 +640,7 @@
       </p:grpSpPr>
       <p:sp>
         <p:nvSpPr>
-          <p:cNvPr id="203" name="PlaceHolder 1"/>
+          <p:cNvPr id="199" name="PlaceHolder 1"/>
           <p:cNvSpPr>
             <a:spLocks noGrp="1"/>
           </p:cNvSpPr>
@@ -663,7 +663,7 @@
       </p:sp>
       <p:sp>
         <p:nvSpPr>
-          <p:cNvPr id="204" name="PlaceHolder 2"/>
+          <p:cNvPr id="200" name="PlaceHolder 2"/>
           <p:cNvSpPr>
             <a:spLocks noGrp="1"/>
           </p:cNvSpPr>
@@ -709,7 +709,7 @@
                 <a:latin typeface="Arial"/>
                 <a:ea typeface="Arial"/>
               </a:rPr>
-              <a:t>React organiza la UI con componentes y estado. Vue utiliza refs y propiedades calculadas. Angular emplea signals en esta implementación. Svelte usa runes y compila los componentes. Estas diferencias no permiten afirmar por sí solas cuál es más rápido: eso depende del escenario y debe medirse. Duración sugerida: 35 segundos.</a:t>
+              <a:t>React se concentra en la interfaz y suele escribir componentes con JSX, una sintaxis que combina JavaScript con marcado. Vue ofrece componentes que separan template, lógica y estilos, y puede adoptarse de forma gradual. Angular integra más herramientas y trabaja principalmente con TypeScript, templates, servicios e inyección de dependencias. Svelte también usa componentes con marcado, lógica y estilos, pero su compilador transforma el código para generar las actualizaciones de la interfaz. [40 segundos]</a:t>
             </a:r>
             <a:endParaRPr lang="en-US" sz="1100" b="0" u="none" strike="noStrike">
               <a:solidFill>
@@ -746,7 +746,7 @@
       </p:grpSpPr>
       <p:sp>
         <p:nvSpPr>
-          <p:cNvPr id="205" name="PlaceHolder 1"/>
+          <p:cNvPr id="201" name="PlaceHolder 1"/>
           <p:cNvSpPr>
             <a:spLocks noGrp="1"/>
           </p:cNvSpPr>
@@ -769,7 +769,7 @@
       </p:sp>
       <p:sp>
         <p:nvSpPr>
-          <p:cNvPr id="206" name="PlaceHolder 2"/>
+          <p:cNvPr id="202" name="PlaceHolder 2"/>
           <p:cNvSpPr>
             <a:spLocks noGrp="1"/>
           </p:cNvSpPr>
@@ -815,7 +815,7 @@
                 <a:latin typeface="Arial"/>
                 <a:ea typeface="Arial"/>
               </a:rPr>
-              <a:t>La metodología evita cambiar varias cosas a la vez. Los datos y las operaciones son equivalentes, aunque el motor reactivo cambia. Usamos producción, el mismo equipo y al menos cinco repeticiones. Limpiar antes de insertar permite comparar el montaje desde cero; insertar dos veces el mismo conjunto puede reutilizar filas existentes. Duración sugerida: 30 segundos.</a:t>
+              <a:t>El estado representa la información que cambia en la aplicación. En React, useState permite actualizarlo y provocar nuevos renders; React reconcilia los cambios para actualizar el DOM. Vue registra dependencias reactivas con herramientas como ref y computed. Angular dispone de signals y de su sistema de detección de cambios. Svelte 5 usa runes como $state y $derived, junto con código generado por el compilador. Tener un compilador o usar signals no garantiza automáticamente mejor rendimiento: hay que medir un escenario concreto. [40 segundos]</a:t>
             </a:r>
             <a:endParaRPr lang="en-US" sz="1100" b="0" u="none" strike="noStrike">
               <a:solidFill>
@@ -852,7 +852,7 @@
       </p:grpSpPr>
       <p:sp>
         <p:nvSpPr>
-          <p:cNvPr id="207" name="PlaceHolder 1"/>
+          <p:cNvPr id="203" name="PlaceHolder 1"/>
           <p:cNvSpPr>
             <a:spLocks noGrp="1"/>
           </p:cNvSpPr>
@@ -875,7 +875,7 @@
       </p:sp>
       <p:sp>
         <p:nvSpPr>
-          <p:cNvPr id="208" name="PlaceHolder 2"/>
+          <p:cNvPr id="204" name="PlaceHolder 2"/>
           <p:cNvSpPr>
             <a:spLocks noGrp="1"/>
           </p:cNvSpPr>
@@ -921,7 +921,7 @@
                 <a:latin typeface="Arial"/>
                 <a:ea typeface="Arial"/>
               </a:rPr>
-              <a:t>La latencia de una interacción incluye retraso de entrada, procesamiento y presentación hasta el siguiente pintado. El panel de INP muestra una métrica de la sesión y no necesariamente la última interacción. Para comparar cada inserción, grabo Performance y selecciono su clic en Interactions. También reviso Scripting, Rendering, Painting y tareas largas. No se están midiendo tiempos de descarga ni carga inicial. Duración sugerida: 35 segundos.</a:t>
+              <a:t>Otra diferencia está en las decisiones que toma el equipo. En React se eligen varias piezas del ecosistema según el proyecto. Vue cuenta con herramientas oficiales como Vue Router y Pinia. Angular integra CLI, router, formularios e inyección de dependencias, y propone más convenciones. Para Svelte, SvelteKit añade capacidades de aplicación como routing y renderizado del lado del servidor. Vite es una herramienta de desarrollo y compilación, no un framework de UI. [35 segundos]</a:t>
             </a:r>
             <a:endParaRPr lang="en-US" sz="1100" b="0" u="none" strike="noStrike">
               <a:solidFill>
@@ -958,7 +958,7 @@
       </p:grpSpPr>
       <p:sp>
         <p:nvSpPr>
-          <p:cNvPr id="209" name="PlaceHolder 1"/>
+          <p:cNvPr id="205" name="PlaceHolder 1"/>
           <p:cNvSpPr>
             <a:spLocks noGrp="1"/>
           </p:cNvSpPr>
@@ -981,7 +981,7 @@
       </p:sp>
       <p:sp>
         <p:nvSpPr>
-          <p:cNvPr id="210" name="PlaceHolder 2"/>
+          <p:cNvPr id="206" name="PlaceHolder 2"/>
           <p:cNvSpPr>
             <a:spLocks noGrp="1"/>
           </p:cNvSpPr>
@@ -1027,7 +1027,7 @@
                 <a:latin typeface="Arial"/>
                 <a:ea typeface="Arial"/>
               </a:rPr>
-              <a:t>Las pruebas del proyecto confirmaron compilación y operaciones funcionales en las cuatro versiones. Eso no demuestra que un framework tenga mejor rendimiento que otro. La conclusión de rendimiento debe limitarse a los escenarios y al equipo de las mediciones. La paginación reduce las filas montadas y es otro escenario válido para comparar. Duración sugerida: 25 segundos.</a:t>
+              <a:t>No hay una tecnología que gane en todos los proyectos. React puede ser adecuado cuando se busca flexibilidad y un ecosistema amplio; Vue facilita una adopción gradual; Angular ofrece herramientas y convenciones integradas; Svelte propone un enfoque basado en compilación. La elección también depende de la experiencia del equipo, las integraciones, el mantenimiento y la complejidad. Para hablar de rendimiento necesitamos condiciones equivalentes y varias mediciones, no solamente un número aislado. [30 segundos]</a:t>
             </a:r>
             <a:endParaRPr lang="en-US" sz="1100" b="0" u="none" strike="noStrike">
               <a:solidFill>
@@ -1064,7 +1064,7 @@
       </p:grpSpPr>
       <p:sp>
         <p:nvSpPr>
-          <p:cNvPr id="211" name="PlaceHolder 1"/>
+          <p:cNvPr id="207" name="PlaceHolder 1"/>
           <p:cNvSpPr>
             <a:spLocks noGrp="1"/>
           </p:cNvSpPr>
@@ -1087,7 +1087,7 @@
       </p:sp>
       <p:sp>
         <p:nvSpPr>
-          <p:cNvPr id="212" name="PlaceHolder 2"/>
+          <p:cNvPr id="208" name="PlaceHolder 2"/>
           <p:cNvSpPr>
             <a:spLocks noGrp="1"/>
           </p:cNvSpPr>
@@ -1133,7 +1133,7 @@
                 <a:latin typeface="Arial"/>
                 <a:ea typeface="Arial"/>
               </a:rPr>
-              <a:t>Paso a la demostración. Primero muestro que las cuatro aplicaciones tienen las mismas funciones. Luego realizo el flujo limpiar e insertar con todas las filas y observo el evento en Performance. Si el tiempo lo permite, repito búsqueda y paginación. Los valores obtenidos en vivo son ilustrativos; para resultados formales uso las medianas de varias repeticiones. Duración sugerida: 15 segundos antes de abrir las aplicaciones.</a:t>
+              <a:t>Para pasar de la teoría a la práctica, implementé InventoryPro en React 18, Vue 3.5, Angular 19 y Svelte 5. Las cuatro versiones tienen los mismos datos y las mismas operaciones de inventario. Mostraré búsqueda, gestión de productos y la inserción de cinco mil registros. Para comparar el montaje elegiré todas las filas, limpiaré la tabla y grabaré la inserción con F12, en Performance. Seleccionaré el clic en Interactions: el INP del panel resume la sesión y no necesariamente representa la última inserción. [25 segundos y pasar a la demostración]</a:t>
             </a:r>
             <a:endParaRPr lang="en-US" sz="1100" b="0" u="none" strike="noStrike">
               <a:solidFill>
@@ -1874,7 +1874,7 @@
                 <a:spcPct val="100000"/>
               </a:lnSpc>
             </a:pPr>
-            <a:fld id="{486C58AB-DC21-4374-8791-6578E075A15E}" type="slidenum">
+            <a:fld id="{4A6D0A41-4823-4D71-AB6E-1D1BF43BCE0E}" type="slidenum">
               <a:rPr lang="es-ES_tradnl" sz="800" b="0" u="none" strike="noStrike">
                 <a:solidFill>
                   <a:srgbClr val="000000"/>
@@ -10899,10 +10899,13 @@
               <a:lnSpc>
                 <a:spcPct val="90000"/>
               </a:lnSpc>
-              <a:buNone/>
-            </a:pPr>
-            <a:r>
-              <a:rPr lang="es-MX" sz="2400" b="1" u="none" strike="noStrike">
+              <a:spcAft>
+                <a:spcPts val="601"/>
+              </a:spcAft>
+              <a:buNone/>
+            </a:pPr>
+            <a:r>
+              <a:rPr lang="es-MX" sz="2500" b="1" u="none" strike="noStrike">
                 <a:solidFill>
                   <a:schemeClr val="lt1"/>
                 </a:solidFill>
@@ -10911,9 +10914,9 @@
                 <a:latin typeface="Verdana"/>
                 <a:ea typeface="Verdana"/>
               </a:rPr>
-              <a:t>Comparación de tecnologías frontend</a:t>
-            </a:r>
-            <a:endParaRPr lang="en-US" sz="2400" b="0" u="none" strike="noStrike">
+              <a:t>React, Vue, Angular y Svelte</a:t>
+            </a:r>
+            <a:endParaRPr lang="en-US" sz="2500" b="0" u="none" strike="noStrike">
               <a:solidFill>
                 <a:srgbClr val="000000"/>
               </a:solidFill>
@@ -10958,6 +10961,9 @@
               <a:lnSpc>
                 <a:spcPct val="100000"/>
               </a:lnSpc>
+              <a:spcAft>
+                <a:spcPts val="601"/>
+              </a:spcAft>
               <a:buClr>
                 <a:srgbClr val="FFFFFF"/>
               </a:buClr>
@@ -10974,7 +10980,7 @@
                 <a:latin typeface="Verdana"/>
                 <a:ea typeface="Verdana"/>
               </a:rPr>
-              <a:t>InventoryPro</a:t>
+              <a:t>Diferencias en arquitectura, reactividad</a:t>
             </a:r>
             <a:endParaRPr lang="en-US" sz="1300" b="0" u="none" strike="noStrike">
               <a:solidFill>
@@ -10990,6 +10996,9 @@
               <a:lnSpc>
                 <a:spcPct val="100000"/>
               </a:lnSpc>
+              <a:spcAft>
+                <a:spcPts val="601"/>
+              </a:spcAft>
               <a:buClr>
                 <a:srgbClr val="FFFFFF"/>
               </a:buClr>
@@ -11006,7 +11015,7 @@
                 <a:latin typeface="Verdana"/>
                 <a:ea typeface="Verdana"/>
               </a:rPr>
-              <a:t>React · Vue · Angular · Svelte</a:t>
+              <a:t>y experiencia de desarrollo</a:t>
             </a:r>
             <a:endParaRPr lang="en-US" sz="1300" b="0" u="none" strike="noStrike">
               <a:solidFill>
@@ -11053,6 +11062,9 @@
               <a:lnSpc>
                 <a:spcPct val="100000"/>
               </a:lnSpc>
+              <a:spcAft>
+                <a:spcPts val="601"/>
+              </a:spcAft>
             </a:pPr>
             <a:r>
               <a:rPr lang="es-PE" sz="1400" b="0" u="none" strike="noStrike">
@@ -11111,6 +11123,9 @@
               <a:lnSpc>
                 <a:spcPct val="100000"/>
               </a:lnSpc>
+              <a:spcAft>
+                <a:spcPts val="601"/>
+              </a:spcAft>
             </a:pPr>
             <a:r>
               <a:rPr lang="es-MX" sz="800" b="0" u="none" strike="noStrike">
@@ -11169,6 +11184,9 @@
               <a:lnSpc>
                 <a:spcPct val="100000"/>
               </a:lnSpc>
+              <a:spcAft>
+                <a:spcPts val="601"/>
+              </a:spcAft>
             </a:pPr>
             <a:r>
               <a:rPr lang="es-MX" sz="790" b="0" u="none" strike="noStrike">
@@ -11227,6 +11245,9 @@
               <a:lnSpc>
                 <a:spcPct val="100000"/>
               </a:lnSpc>
+              <a:spcAft>
+                <a:spcPts val="601"/>
+              </a:spcAft>
               <a:tabLst>
                 <a:tab pos="0" algn="l"/>
               </a:tabLst>
@@ -11257,6 +11278,9 @@
               <a:lnSpc>
                 <a:spcPct val="100000"/>
               </a:lnSpc>
+              <a:spcAft>
+                <a:spcPts val="601"/>
+              </a:spcAft>
               <a:tabLst>
                 <a:tab pos="0" algn="l"/>
               </a:tabLst>
@@ -11360,6 +11384,9 @@
               <a:lnSpc>
                 <a:spcPct val="100000"/>
               </a:lnSpc>
+              <a:spcAft>
+                <a:spcPts val="601"/>
+              </a:spcAft>
             </a:pPr>
             <a:r>
               <a:rPr lang="es-PE" sz="1100" b="0" u="none" strike="noStrike">
@@ -11371,7 +11398,7 @@
                 <a:latin typeface="Verdana"/>
                 <a:ea typeface="Verdana"/>
               </a:rPr>
-              <a:t>Una aplicación, cuatro implementaciones</a:t>
+              <a:t>Comparación de tecnologías frontend</a:t>
             </a:r>
             <a:endParaRPr lang="en-US" sz="1100" b="0" u="none" strike="noStrike">
               <a:solidFill>
@@ -11446,6 +11473,9 @@
               <a:lnSpc>
                 <a:spcPct val="100000"/>
               </a:lnSpc>
+              <a:spcAft>
+                <a:spcPts val="601"/>
+              </a:spcAft>
               <a:buNone/>
             </a:pPr>
             <a:r>
@@ -11458,7 +11488,7 @@
                 <a:latin typeface="Verdana"/>
                 <a:ea typeface="Verdana"/>
               </a:rPr>
-              <a:t>El caso de estudio: InventoryPro</a:t>
+              <a:t>¿Qué diferencias vamos a comparar?</a:t>
             </a:r>
             <a:endParaRPr lang="en-US" sz="2300" b="0" u="none" strike="noStrike">
               <a:solidFill>
@@ -11503,6 +11533,9 @@
               <a:lnSpc>
                 <a:spcPct val="100000"/>
               </a:lnSpc>
+              <a:spcAft>
+                <a:spcPts val="601"/>
+              </a:spcAft>
               <a:buNone/>
               <a:tabLst>
                 <a:tab pos="0" algn="l"/>
@@ -11518,7 +11551,7 @@
                 <a:latin typeface="Verdana"/>
                 <a:ea typeface="Verdana"/>
               </a:rPr>
-              <a:t>Mismas funciones en las cuatro versiones:</a:t>
+              <a:t>Cuatro tecnologías para construir interfaces web.</a:t>
             </a:r>
             <a:endParaRPr lang="en-US" sz="1600" b="0" u="none" strike="noStrike">
               <a:solidFill>
@@ -11534,6 +11567,9 @@
               <a:lnSpc>
                 <a:spcPct val="100000"/>
               </a:lnSpc>
+              <a:spcAft>
+                <a:spcPts val="601"/>
+              </a:spcAft>
               <a:buNone/>
               <a:tabLst>
                 <a:tab pos="0" algn="l"/>
@@ -11553,6 +11589,9 @@
               <a:lnSpc>
                 <a:spcPct val="100000"/>
               </a:lnSpc>
+              <a:spcAft>
+                <a:spcPts val="601"/>
+              </a:spcAft>
               <a:buNone/>
               <a:tabLst>
                 <a:tab pos="0" algn="l"/>
@@ -11568,7 +11607,7 @@
                 <a:latin typeface="Verdana"/>
                 <a:ea typeface="Verdana"/>
               </a:rPr>
-              <a:t>• Dashboard y métricas del inventario.</a:t>
+              <a:t>• Alcance: biblioteca o framework.</a:t>
             </a:r>
             <a:endParaRPr lang="en-US" sz="1600" b="0" u="none" strike="noStrike">
               <a:solidFill>
@@ -11584,6 +11623,9 @@
               <a:lnSpc>
                 <a:spcPct val="100000"/>
               </a:lnSpc>
+              <a:spcAft>
+                <a:spcPts val="601"/>
+              </a:spcAft>
               <a:buNone/>
               <a:tabLst>
                 <a:tab pos="0" algn="l"/>
@@ -11599,7 +11641,7 @@
                 <a:latin typeface="Verdana"/>
                 <a:ea typeface="Verdana"/>
               </a:rPr>
-              <a:t>• Búsqueda, filtros, orden y paginación.</a:t>
+              <a:t>• Componentes, sintaxis y lenguaje.</a:t>
             </a:r>
             <a:endParaRPr lang="en-US" sz="1600" b="0" u="none" strike="noStrike">
               <a:solidFill>
@@ -11615,6 +11657,9 @@
               <a:lnSpc>
                 <a:spcPct val="100000"/>
               </a:lnSpc>
+              <a:spcAft>
+                <a:spcPts val="601"/>
+              </a:spcAft>
               <a:buNone/>
               <a:tabLst>
                 <a:tab pos="0" algn="l"/>
@@ -11630,7 +11675,7 @@
                 <a:latin typeface="Verdana"/>
                 <a:ea typeface="Verdana"/>
               </a:rPr>
-              <a:t>• Crear, editar y eliminar productos.</a:t>
+              <a:t>• Estado y actualización de la interfaz.</a:t>
             </a:r>
             <a:endParaRPr lang="en-US" sz="1600" b="0" u="none" strike="noStrike">
               <a:solidFill>
@@ -11646,6 +11691,9 @@
               <a:lnSpc>
                 <a:spcPct val="100000"/>
               </a:lnSpc>
+              <a:spcAft>
+                <a:spcPts val="601"/>
+              </a:spcAft>
               <a:buNone/>
               <a:tabLst>
                 <a:tab pos="0" algn="l"/>
@@ -11661,7 +11709,7 @@
                 <a:latin typeface="Verdana"/>
                 <a:ea typeface="Verdana"/>
               </a:rPr>
-              <a:t>• Insertar 1.000, 2.000 o 5.000 registros.</a:t>
+              <a:t>• Herramientas y organización del proyecto.</a:t>
             </a:r>
             <a:endParaRPr lang="en-US" sz="1600" b="0" u="none" strike="noStrike">
               <a:solidFill>
@@ -11677,6 +11725,9 @@
               <a:lnSpc>
                 <a:spcPct val="100000"/>
               </a:lnSpc>
+              <a:spcAft>
+                <a:spcPts val="601"/>
+              </a:spcAft>
               <a:buNone/>
               <a:tabLst>
                 <a:tab pos="0" algn="l"/>
@@ -11692,7 +11743,7 @@
                 <a:latin typeface="Verdana"/>
                 <a:ea typeface="Verdana"/>
               </a:rPr>
-              <a:t>• Limpiar para repetir el montaje desde cero.</a:t>
+              <a:t>• Criterios para elegir según el contexto.</a:t>
             </a:r>
             <a:endParaRPr lang="en-US" sz="1600" b="0" u="none" strike="noStrike">
               <a:solidFill>
@@ -13696,7 +13747,7 @@
                 <a:latin typeface="Verdana"/>
                 <a:ea typeface="Verdana"/>
               </a:rPr>
-              <a:t>MISMA</a:t>
+              <a:t>CUATRO</a:t>
             </a:r>
             <a:endParaRPr lang="en-US" sz="2500" b="0" u="none" strike="noStrike">
               <a:solidFill>
@@ -13712,6 +13763,9 @@
               <a:lnSpc>
                 <a:spcPct val="100000"/>
               </a:lnSpc>
+              <a:spcAft>
+                <a:spcPts val="601"/>
+              </a:spcAft>
               <a:buNone/>
               <a:tabLst>
                 <a:tab pos="0" algn="l"/>
@@ -13727,7 +13781,7 @@
                 <a:latin typeface="Verdana"/>
                 <a:ea typeface="Verdana"/>
               </a:rPr>
-              <a:t>APLICACIÓN</a:t>
+              <a:t>ENFOQUES</a:t>
             </a:r>
             <a:endParaRPr lang="en-US" sz="2500" b="0" u="none" strike="noStrike">
               <a:solidFill>
@@ -13787,7 +13841,7 @@
                 <a:latin typeface="Verdana"/>
                 <a:ea typeface="Verdana"/>
               </a:rPr>
-              <a:t>Cuatro enfoques de interfaz</a:t>
+              <a:t>Arquitectura y componentes</a:t>
             </a:r>
             <a:endParaRPr lang="en-US" sz="2000" b="0" u="none" strike="noStrike">
               <a:solidFill>
@@ -13847,7 +13901,7 @@
                 <a:latin typeface="Verdana"/>
                 <a:ea typeface="Verdana"/>
               </a:rPr>
-              <a:t>React 18</a:t>
+              <a:t>React</a:t>
             </a:r>
             <a:endParaRPr lang="en-US" sz="1600" b="0" u="none" strike="noStrike">
               <a:solidFill>
@@ -13923,6 +13977,9 @@
               <a:lnSpc>
                 <a:spcPct val="100000"/>
               </a:lnSpc>
+              <a:spcAft>
+                <a:spcPts val="601"/>
+              </a:spcAft>
               <a:buNone/>
               <a:tabLst>
                 <a:tab pos="0" algn="l"/>
@@ -13938,7 +13995,7 @@
                 <a:latin typeface="Verdana"/>
                 <a:ea typeface="Verdana"/>
               </a:rPr>
-              <a:t>useState y useMemo</a:t>
+              <a:t>Componentes con JSX</a:t>
             </a:r>
             <a:endParaRPr lang="en-US" sz="1200" b="0" u="none" strike="noStrike">
               <a:solidFill>
@@ -13954,6 +14011,9 @@
               <a:lnSpc>
                 <a:spcPct val="100000"/>
               </a:lnSpc>
+              <a:spcAft>
+                <a:spcPts val="601"/>
+              </a:spcAft>
               <a:buNone/>
               <a:tabLst>
                 <a:tab pos="0" algn="l"/>
@@ -13969,7 +14029,7 @@
                 <a:latin typeface="Verdana"/>
                 <a:ea typeface="Verdana"/>
               </a:rPr>
-              <a:t>Componentes JSX</a:t>
+              <a:t>Más decisiones de integración</a:t>
             </a:r>
             <a:endParaRPr lang="en-US" sz="1200" b="0" u="none" strike="noStrike">
               <a:solidFill>
@@ -14029,7 +14089,7 @@
                 <a:latin typeface="Verdana"/>
                 <a:ea typeface="Verdana"/>
               </a:rPr>
-              <a:t>Vue 3.5</a:t>
+              <a:t>Vue</a:t>
             </a:r>
             <a:endParaRPr lang="en-US" sz="1600" b="0" u="none" strike="noStrike">
               <a:solidFill>
@@ -14105,6 +14165,9 @@
               <a:lnSpc>
                 <a:spcPct val="100000"/>
               </a:lnSpc>
+              <a:spcAft>
+                <a:spcPts val="601"/>
+              </a:spcAft>
               <a:buNone/>
               <a:tabLst>
                 <a:tab pos="0" algn="l"/>
@@ -14120,7 +14183,7 @@
                 <a:latin typeface="Verdana"/>
                 <a:ea typeface="Verdana"/>
               </a:rPr>
-              <a:t>ref y computed</a:t>
+              <a:t>Template, script y estilos</a:t>
             </a:r>
             <a:endParaRPr lang="en-US" sz="1200" b="0" u="none" strike="noStrike">
               <a:solidFill>
@@ -14136,6 +14199,9 @@
               <a:lnSpc>
                 <a:spcPct val="100000"/>
               </a:lnSpc>
+              <a:spcAft>
+                <a:spcPts val="601"/>
+              </a:spcAft>
               <a:buNone/>
               <a:tabLst>
                 <a:tab pos="0" algn="l"/>
@@ -14151,7 +14217,7 @@
                 <a:latin typeface="Verdana"/>
                 <a:ea typeface="Verdana"/>
               </a:rPr>
-              <a:t>Reactividad con proxies</a:t>
+              <a:t>Adopción gradual</a:t>
             </a:r>
             <a:endParaRPr lang="en-US" sz="1200" b="0" u="none" strike="noStrike">
               <a:solidFill>
@@ -14211,7 +14277,7 @@
                 <a:latin typeface="Verdana"/>
                 <a:ea typeface="Verdana"/>
               </a:rPr>
-              <a:t>Angular 19</a:t>
+              <a:t>Angular</a:t>
             </a:r>
             <a:endParaRPr lang="en-US" sz="1600" b="0" u="none" strike="noStrike">
               <a:solidFill>
@@ -14287,6 +14353,9 @@
               <a:lnSpc>
                 <a:spcPct val="100000"/>
               </a:lnSpc>
+              <a:spcAft>
+                <a:spcPts val="601"/>
+              </a:spcAft>
               <a:buNone/>
               <a:tabLst>
                 <a:tab pos="0" algn="l"/>
@@ -14302,7 +14371,7 @@
                 <a:latin typeface="Verdana"/>
                 <a:ea typeface="Verdana"/>
               </a:rPr>
-              <a:t>Signals y computed</a:t>
+              <a:t>TypeScript y templates</a:t>
             </a:r>
             <a:endParaRPr lang="en-US" sz="1200" b="0" u="none" strike="noStrike">
               <a:solidFill>
@@ -14318,6 +14387,9 @@
               <a:lnSpc>
                 <a:spcPct val="100000"/>
               </a:lnSpc>
+              <a:spcAft>
+                <a:spcPts val="601"/>
+              </a:spcAft>
               <a:buNone/>
               <a:tabLst>
                 <a:tab pos="0" algn="l"/>
@@ -14333,7 +14405,7 @@
                 <a:latin typeface="Verdana"/>
                 <a:ea typeface="Verdana"/>
               </a:rPr>
-              <a:t>Componentes standalone</a:t>
+              <a:t>Servicios e inyección</a:t>
             </a:r>
             <a:endParaRPr lang="en-US" sz="1200" b="0" u="none" strike="noStrike">
               <a:solidFill>
@@ -14393,7 +14465,7 @@
                 <a:latin typeface="Verdana"/>
                 <a:ea typeface="Verdana"/>
               </a:rPr>
-              <a:t>Svelte 5</a:t>
+              <a:t>Svelte</a:t>
             </a:r>
             <a:endParaRPr lang="en-US" sz="1600" b="0" u="none" strike="noStrike">
               <a:solidFill>
@@ -14453,7 +14525,7 @@
                 <a:latin typeface="Verdana"/>
                 <a:ea typeface="Verdana"/>
               </a:rPr>
-              <a:t>Compilador de UI</a:t>
+              <a:t>Framework con compilador</a:t>
             </a:r>
             <a:endParaRPr lang="en-US" sz="1200" b="0" u="none" strike="noStrike">
               <a:solidFill>
@@ -14469,6 +14541,9 @@
               <a:lnSpc>
                 <a:spcPct val="100000"/>
               </a:lnSpc>
+              <a:spcAft>
+                <a:spcPts val="601"/>
+              </a:spcAft>
               <a:buNone/>
               <a:tabLst>
                 <a:tab pos="0" algn="l"/>
@@ -14484,7 +14559,7 @@
                 <a:latin typeface="Verdana"/>
                 <a:ea typeface="Verdana"/>
               </a:rPr>
-              <a:t>$state y $derived</a:t>
+              <a:t>HTML, script y estilos</a:t>
             </a:r>
             <a:endParaRPr lang="en-US" sz="1200" b="0" u="none" strike="noStrike">
               <a:solidFill>
@@ -14500,6 +14575,9 @@
               <a:lnSpc>
                 <a:spcPct val="100000"/>
               </a:lnSpc>
+              <a:spcAft>
+                <a:spcPts val="601"/>
+              </a:spcAft>
               <a:buNone/>
               <a:tabLst>
                 <a:tab pos="0" algn="l"/>
@@ -14515,7 +14593,7 @@
                 <a:latin typeface="Verdana"/>
                 <a:ea typeface="Verdana"/>
               </a:rPr>
-              <a:t>Código generado</a:t>
+              <a:t>Transformación al compilar</a:t>
             </a:r>
             <a:endParaRPr lang="en-US" sz="1200" b="0" u="none" strike="noStrike">
               <a:solidFill>
@@ -14605,7 +14683,7 @@
                 <a:latin typeface="Verdana"/>
                 <a:ea typeface="Verdana"/>
               </a:rPr>
-              <a:t>Una comparación bajo las mismas condiciones</a:t>
+              <a:t>¿Cómo cambia el estado y se actualiza la UI?</a:t>
             </a:r>
             <a:endParaRPr lang="en-US" sz="2200" b="0" u="none" strike="noStrike">
               <a:solidFill>
@@ -14665,7 +14743,7 @@
                 <a:latin typeface="Verdana"/>
                 <a:ea typeface="Verdana"/>
               </a:rPr>
-              <a:t>MISMO ESCENARIO</a:t>
+              <a:t>REACT Y VUE</a:t>
             </a:r>
             <a:endParaRPr lang="en-US" sz="1700" b="0" u="none" strike="noStrike">
               <a:solidFill>
@@ -14691,7 +14769,7 @@
         <p:spPr>
           <a:xfrm>
             <a:off x="673200" y="2743560"/>
-            <a:ext cx="3251520" cy="1285920"/>
+            <a:ext cx="3251520" cy="1737000"/>
           </a:xfrm>
           <a:prstGeom prst="rect">
             <a:avLst/>
@@ -14716,7 +14794,7 @@
               </a:tabLst>
             </a:pPr>
             <a:r>
-              <a:rPr lang="es" sz="1500" b="0" u="none" strike="noStrike">
+              <a:rPr lang="es" sz="1400" b="0" u="none" strike="noStrike">
                 <a:solidFill>
                   <a:schemeClr val="dk1"/>
                 </a:solidFill>
@@ -14725,9 +14803,9 @@
                 <a:latin typeface="Verdana"/>
                 <a:ea typeface="Verdana"/>
               </a:rPr>
-              <a:t>Datos con semilla fija.</a:t>
-            </a:r>
-            <a:endParaRPr lang="en-US" sz="1500" b="0" u="none" strike="noStrike">
+              <a:t>React: hooks como useState.</a:t>
+            </a:r>
+            <a:endParaRPr lang="en-US" sz="1400" b="0" u="none" strike="noStrike">
               <a:solidFill>
                 <a:srgbClr val="000000"/>
               </a:solidFill>
@@ -14741,13 +14819,16 @@
               <a:lnSpc>
                 <a:spcPct val="100000"/>
               </a:lnSpc>
+              <a:spcAft>
+                <a:spcPts val="601"/>
+              </a:spcAft>
               <a:buNone/>
               <a:tabLst>
                 <a:tab pos="0" algn="l"/>
               </a:tabLst>
             </a:pPr>
             <a:r>
-              <a:rPr lang="es" sz="1500" b="0" u="none" strike="noStrike">
+              <a:rPr lang="es" sz="1400" b="0" u="none" strike="noStrike">
                 <a:solidFill>
                   <a:schemeClr val="dk1"/>
                 </a:solidFill>
@@ -14756,9 +14837,9 @@
                 <a:latin typeface="Verdana"/>
                 <a:ea typeface="Verdana"/>
               </a:rPr>
-              <a:t>Funciones y reglas equivalentes.</a:t>
-            </a:r>
-            <a:endParaRPr lang="en-US" sz="1500" b="0" u="none" strike="noStrike">
+              <a:t>Ejecuta componentes y reconcilia cambios.</a:t>
+            </a:r>
+            <a:endParaRPr lang="en-US" sz="1400" b="0" u="none" strike="noStrike">
               <a:solidFill>
                 <a:srgbClr val="000000"/>
               </a:solidFill>
@@ -14772,24 +14853,15 @@
               <a:lnSpc>
                 <a:spcPct val="100000"/>
               </a:lnSpc>
+              <a:spcAft>
+                <a:spcPts val="601"/>
+              </a:spcAft>
               <a:buNone/>
               <a:tabLst>
                 <a:tab pos="0" algn="l"/>
               </a:tabLst>
             </a:pPr>
-            <a:r>
-              <a:rPr lang="es" sz="1500" b="0" u="none" strike="noStrike">
-                <a:solidFill>
-                  <a:schemeClr val="dk1"/>
-                </a:solidFill>
-                <a:effectLst/>
-                <a:uFillTx/>
-                <a:latin typeface="Verdana"/>
-                <a:ea typeface="Verdana"/>
-              </a:rPr>
-              <a:t>Misma laptop y navegador.</a:t>
-            </a:r>
-            <a:endParaRPr lang="en-US" sz="1500" b="0" u="none" strike="noStrike">
+            <a:endParaRPr lang="en-US" sz="1400" b="0" u="none" strike="noStrike">
               <a:solidFill>
                 <a:srgbClr val="000000"/>
               </a:solidFill>
@@ -14803,13 +14875,16 @@
               <a:lnSpc>
                 <a:spcPct val="100000"/>
               </a:lnSpc>
+              <a:spcAft>
+                <a:spcPts val="601"/>
+              </a:spcAft>
               <a:buNone/>
               <a:tabLst>
                 <a:tab pos="0" algn="l"/>
               </a:tabLst>
             </a:pPr>
             <a:r>
-              <a:rPr lang="es" sz="1500" b="0" u="none" strike="noStrike">
+              <a:rPr lang="es" sz="1400" b="0" u="none" strike="noStrike">
                 <a:solidFill>
                   <a:schemeClr val="dk1"/>
                 </a:solidFill>
@@ -14818,9 +14893,43 @@
                 <a:latin typeface="Verdana"/>
                 <a:ea typeface="Verdana"/>
               </a:rPr>
-              <a:t>Builds de producción.</a:t>
-            </a:r>
-            <a:endParaRPr lang="en-US" sz="1500" b="0" u="none" strike="noStrike">
+              <a:t>Vue: ref y computed.</a:t>
+            </a:r>
+            <a:endParaRPr lang="en-US" sz="1400" b="0" u="none" strike="noStrike">
+              <a:solidFill>
+                <a:srgbClr val="000000"/>
+              </a:solidFill>
+              <a:effectLst/>
+              <a:uFillTx/>
+              <a:latin typeface="Arial"/>
+            </a:endParaRPr>
+          </a:p>
+          <a:p>
+            <a:pPr indent="0" algn="l">
+              <a:lnSpc>
+                <a:spcPct val="100000"/>
+              </a:lnSpc>
+              <a:spcAft>
+                <a:spcPts val="601"/>
+              </a:spcAft>
+              <a:buNone/>
+              <a:tabLst>
+                <a:tab pos="0" algn="l"/>
+              </a:tabLst>
+            </a:pPr>
+            <a:r>
+              <a:rPr lang="es" sz="1400" b="0" u="none" strike="noStrike">
+                <a:solidFill>
+                  <a:schemeClr val="dk1"/>
+                </a:solidFill>
+                <a:effectLst/>
+                <a:uFillTx/>
+                <a:latin typeface="Verdana"/>
+                <a:ea typeface="Verdana"/>
+              </a:rPr>
+              <a:t>Rastrea dependencias reactivas.</a:t>
+            </a:r>
+            <a:endParaRPr lang="en-US" sz="1400" b="0" u="none" strike="noStrike">
               <a:solidFill>
                 <a:srgbClr val="000000"/>
               </a:solidFill>
@@ -14878,7 +14987,7 @@
                 <a:latin typeface="Verdana"/>
                 <a:ea typeface="Verdana"/>
               </a:rPr>
-              <a:t>PRUEBAS REPETIBLES</a:t>
+              <a:t>ANGULAR Y SVELTE</a:t>
             </a:r>
             <a:endParaRPr lang="en-US" sz="1700" b="0" u="none" strike="noStrike">
               <a:solidFill>
@@ -14904,7 +15013,7 @@
         <p:spPr>
           <a:xfrm>
             <a:off x="4785480" y="2743560"/>
-            <a:ext cx="3251520" cy="1285920"/>
+            <a:ext cx="3251520" cy="1737000"/>
           </a:xfrm>
           <a:prstGeom prst="rect">
             <a:avLst/>
@@ -14929,7 +15038,7 @@
               </a:tabLst>
             </a:pPr>
             <a:r>
-              <a:rPr lang="es" sz="1500" b="0" u="none" strike="noStrike">
+              <a:rPr lang="es" sz="1400" b="0" u="none" strike="noStrike">
                 <a:solidFill>
                   <a:schemeClr val="dk1"/>
                 </a:solidFill>
@@ -14938,9 +15047,9 @@
                 <a:latin typeface="Verdana"/>
                 <a:ea typeface="Verdana"/>
               </a:rPr>
-              <a:t>Limpiar → insertar.</a:t>
-            </a:r>
-            <a:endParaRPr lang="en-US" sz="1500" b="0" u="none" strike="noStrike">
+              <a:t>Angular: signals y detección de cambios.</a:t>
+            </a:r>
+            <a:endParaRPr lang="en-US" sz="1400" b="0" u="none" strike="noStrike">
               <a:solidFill>
                 <a:srgbClr val="000000"/>
               </a:solidFill>
@@ -14954,24 +15063,15 @@
               <a:lnSpc>
                 <a:spcPct val="100000"/>
               </a:lnSpc>
+              <a:spcAft>
+                <a:spcPts val="601"/>
+              </a:spcAft>
               <a:buNone/>
               <a:tabLst>
                 <a:tab pos="0" algn="l"/>
               </a:tabLst>
             </a:pPr>
-            <a:r>
-              <a:rPr lang="es" sz="1500" b="0" u="none" strike="noStrike">
-                <a:solidFill>
-                  <a:schemeClr val="dk1"/>
-                </a:solidFill>
-                <a:effectLst/>
-                <a:uFillTx/>
-                <a:latin typeface="Verdana"/>
-                <a:ea typeface="Verdana"/>
-              </a:rPr>
-              <a:t>Al menos 5 repeticiones por caso.</a:t>
-            </a:r>
-            <a:endParaRPr lang="en-US" sz="1500" b="0" u="none" strike="noStrike">
+            <a:endParaRPr lang="en-US" sz="1400" b="0" u="none" strike="noStrike">
               <a:solidFill>
                 <a:srgbClr val="000000"/>
               </a:solidFill>
@@ -14985,13 +15085,16 @@
               <a:lnSpc>
                 <a:spcPct val="100000"/>
               </a:lnSpc>
+              <a:spcAft>
+                <a:spcPts val="601"/>
+              </a:spcAft>
               <a:buNone/>
               <a:tabLst>
                 <a:tab pos="0" algn="l"/>
               </a:tabLst>
             </a:pPr>
             <a:r>
-              <a:rPr lang="es" sz="1500" b="0" u="none" strike="noStrike">
+              <a:rPr lang="es" sz="1400" b="0" u="none" strike="noStrike">
                 <a:solidFill>
                   <a:schemeClr val="dk1"/>
                 </a:solidFill>
@@ -15000,9 +15103,9 @@
                 <a:latin typeface="Verdana"/>
                 <a:ea typeface="Verdana"/>
               </a:rPr>
-              <a:t>Comparar la mediana.</a:t>
-            </a:r>
-            <a:endParaRPr lang="en-US" sz="1500" b="0" u="none" strike="noStrike">
+              <a:t>Svelte 5: runes como $state y $derived.</a:t>
+            </a:r>
+            <a:endParaRPr lang="en-US" sz="1400" b="0" u="none" strike="noStrike">
               <a:solidFill>
                 <a:srgbClr val="000000"/>
               </a:solidFill>
@@ -15016,13 +15119,16 @@
               <a:lnSpc>
                 <a:spcPct val="100000"/>
               </a:lnSpc>
+              <a:spcAft>
+                <a:spcPts val="601"/>
+              </a:spcAft>
               <a:buNone/>
               <a:tabLst>
                 <a:tab pos="0" algn="l"/>
               </a:tabLst>
             </a:pPr>
             <a:r>
-              <a:rPr lang="es" sz="1500" b="0" u="none" strike="noStrike">
+              <a:rPr lang="es" sz="1400" b="0" u="none" strike="noStrike">
                 <a:solidFill>
                   <a:schemeClr val="dk1"/>
                 </a:solidFill>
@@ -15031,96 +15137,8 @@
                 <a:latin typeface="Verdana"/>
                 <a:ea typeface="Verdana"/>
               </a:rPr>
-              <a:t>Todas las filas y paginación.</a:t>
-            </a:r>
-            <a:endParaRPr lang="en-US" sz="1500" b="0" u="none" strike="noStrike">
-              <a:solidFill>
-                <a:srgbClr val="000000"/>
-              </a:solidFill>
-              <a:effectLst/>
-              <a:uFillTx/>
-              <a:latin typeface="Arial"/>
-            </a:endParaRPr>
-          </a:p>
-        </p:txBody>
-      </p:sp>
-      <p:sp>
-        <p:nvSpPr>
-          <p:cNvPr id="180" name="Google Shape;216;p28"/>
-          <p:cNvSpPr/>
-          <p:nvPr/>
-        </p:nvSpPr>
-        <p:spPr>
-          <a:xfrm>
-            <a:off x="768240" y="3946680"/>
-            <a:ext cx="165960" cy="37080"/>
-          </a:xfrm>
-          <a:prstGeom prst="rect">
-            <a:avLst/>
-          </a:prstGeom>
-          <a:solidFill>
-            <a:srgbClr val="FF3A00"/>
-          </a:solidFill>
-          <a:ln w="0">
-            <a:noFill/>
-          </a:ln>
-        </p:spPr>
-        <p:style>
-          <a:lnRef idx="0"/>
-          <a:fillRef idx="0"/>
-          <a:effectRef idx="0"/>
-          <a:fontRef idx="minor"/>
-        </p:style>
-        <p:txBody>
-          <a:bodyPr lIns="83160" tIns="18720" rIns="83160" bIns="18720" anchor="ctr">
-            <a:noAutofit/>
-          </a:bodyPr>
-          <a:p>
-            <a:pPr/>
-            <a:endParaRPr lang="en-US" sz="1400" b="0" u="none" strike="noStrike">
-              <a:solidFill>
-                <a:srgbClr val="000000"/>
-              </a:solidFill>
-              <a:effectLst/>
-              <a:uFillTx/>
-              <a:latin typeface="Arial"/>
-            </a:endParaRPr>
-          </a:p>
-        </p:txBody>
-      </p:sp>
-      <p:sp>
-        <p:nvSpPr>
-          <p:cNvPr id="181" name="Google Shape;216;p28"/>
-          <p:cNvSpPr/>
-          <p:nvPr/>
-        </p:nvSpPr>
-        <p:spPr>
-          <a:xfrm>
-            <a:off x="4880160" y="3946680"/>
-            <a:ext cx="165960" cy="37080"/>
-          </a:xfrm>
-          <a:prstGeom prst="rect">
-            <a:avLst/>
-          </a:prstGeom>
-          <a:solidFill>
-            <a:srgbClr val="FF3A00"/>
-          </a:solidFill>
-          <a:ln w="0">
-            <a:noFill/>
-          </a:ln>
-        </p:spPr>
-        <p:style>
-          <a:lnRef idx="0"/>
-          <a:fillRef idx="0"/>
-          <a:effectRef idx="0"/>
-          <a:fontRef idx="minor"/>
-        </p:style>
-        <p:txBody>
-          <a:bodyPr lIns="83160" tIns="18720" rIns="83160" bIns="18720" anchor="ctr">
-            <a:noAutofit/>
-          </a:bodyPr>
-          <a:p>
-            <a:pPr/>
+              <a:t>El compilador genera actualizaciones.</a:t>
+            </a:r>
             <a:endParaRPr lang="en-US" sz="1400" b="0" u="none" strike="noStrike">
               <a:solidFill>
                 <a:srgbClr val="000000"/>
@@ -15164,7 +15182,7 @@
       </p:grpSpPr>
       <p:sp>
         <p:nvSpPr>
-          <p:cNvPr id="182" name="PlaceHolder 1"/>
+          <p:cNvPr id="180" name="PlaceHolder 1"/>
           <p:cNvSpPr>
             <a:spLocks noGrp="1"/>
           </p:cNvSpPr>
@@ -15209,7 +15227,7 @@
                 <a:latin typeface="Verdana"/>
                 <a:ea typeface="Verdana"/>
               </a:rPr>
-              <a:t>ENTRADA</a:t>
+              <a:t>REACT / VUE</a:t>
             </a:r>
             <a:endParaRPr lang="en-US" sz="1600" b="0" u="none" strike="noStrike">
               <a:solidFill>
@@ -15224,7 +15242,7 @@
       </p:sp>
       <p:sp>
         <p:nvSpPr>
-          <p:cNvPr id="183" name="PlaceHolder 2"/>
+          <p:cNvPr id="181" name="PlaceHolder 2"/>
           <p:cNvSpPr>
             <a:spLocks noGrp="1"/>
           </p:cNvSpPr>
@@ -15235,7 +15253,7 @@
         <p:spPr>
           <a:xfrm>
             <a:off x="575640" y="2503800"/>
-            <a:ext cx="2448360" cy="1285920"/>
+            <a:ext cx="2448360" cy="1462680"/>
           </a:xfrm>
           <a:prstGeom prst="rect">
             <a:avLst/>
@@ -15260,7 +15278,7 @@
               </a:tabLst>
             </a:pPr>
             <a:r>
-              <a:rPr lang="es" sz="1500" b="0" u="none" strike="noStrike">
+              <a:rPr lang="es" sz="1300" b="0" u="none" strike="noStrike">
                 <a:solidFill>
                   <a:schemeClr val="dk1"/>
                 </a:solidFill>
@@ -15269,9 +15287,77 @@
                 <a:latin typeface="Verdana"/>
                 <a:ea typeface="Verdana"/>
               </a:rPr>
-              <a:t>Espera antes de ejecutar el manejador del evento.</a:t>
-            </a:r>
-            <a:endParaRPr lang="en-US" sz="1500" b="0" u="none" strike="noStrike">
+              <a:t>React: ecosistema modular.</a:t>
+            </a:r>
+            <a:endParaRPr lang="en-US" sz="1300" b="0" u="none" strike="noStrike">
+              <a:solidFill>
+                <a:srgbClr val="000000"/>
+              </a:solidFill>
+              <a:effectLst/>
+              <a:uFillTx/>
+              <a:latin typeface="Arial"/>
+            </a:endParaRPr>
+          </a:p>
+          <a:p>
+            <a:pPr indent="0" algn="l">
+              <a:lnSpc>
+                <a:spcPct val="100000"/>
+              </a:lnSpc>
+              <a:spcAft>
+                <a:spcPts val="601"/>
+              </a:spcAft>
+              <a:buNone/>
+              <a:tabLst>
+                <a:tab pos="0" algn="l"/>
+              </a:tabLst>
+            </a:pPr>
+            <a:r>
+              <a:rPr lang="es" sz="1300" b="0" u="none" strike="noStrike">
+                <a:solidFill>
+                  <a:schemeClr val="dk1"/>
+                </a:solidFill>
+                <a:effectLst/>
+                <a:uFillTx/>
+                <a:latin typeface="Verdana"/>
+                <a:ea typeface="Verdana"/>
+              </a:rPr>
+              <a:t>Vue: Router y Pinia oficiales.</a:t>
+            </a:r>
+            <a:endParaRPr lang="en-US" sz="1300" b="0" u="none" strike="noStrike">
+              <a:solidFill>
+                <a:srgbClr val="000000"/>
+              </a:solidFill>
+              <a:effectLst/>
+              <a:uFillTx/>
+              <a:latin typeface="Arial"/>
+            </a:endParaRPr>
+          </a:p>
+          <a:p>
+            <a:pPr indent="0" algn="l">
+              <a:lnSpc>
+                <a:spcPct val="100000"/>
+              </a:lnSpc>
+              <a:spcAft>
+                <a:spcPts val="601"/>
+              </a:spcAft>
+              <a:buNone/>
+              <a:tabLst>
+                <a:tab pos="0" algn="l"/>
+              </a:tabLst>
+            </a:pPr>
+            <a:r>
+              <a:rPr lang="es" sz="1300" b="0" u="none" strike="noStrike">
+                <a:solidFill>
+                  <a:schemeClr val="dk1"/>
+                </a:solidFill>
+                <a:effectLst/>
+                <a:uFillTx/>
+                <a:latin typeface="Verdana"/>
+                <a:ea typeface="Verdana"/>
+              </a:rPr>
+              <a:t>Vite es una opción habitual.</a:t>
+            </a:r>
+            <a:endParaRPr lang="en-US" sz="1300" b="0" u="none" strike="noStrike">
               <a:solidFill>
                 <a:srgbClr val="000000"/>
               </a:solidFill>
@@ -15284,7 +15370,7 @@
       </p:sp>
       <p:sp>
         <p:nvSpPr>
-          <p:cNvPr id="184" name="PlaceHolder 3"/>
+          <p:cNvPr id="182" name="PlaceHolder 3"/>
           <p:cNvSpPr>
             <a:spLocks noGrp="1"/>
           </p:cNvSpPr>
@@ -15329,7 +15415,7 @@
                 <a:latin typeface="Verdana"/>
                 <a:ea typeface="Verdana"/>
               </a:rPr>
-              <a:t>PROCESAMIENTO</a:t>
+              <a:t>ANGULAR</a:t>
             </a:r>
             <a:endParaRPr lang="en-US" sz="1600" b="0" u="none" strike="noStrike">
               <a:solidFill>
@@ -15344,7 +15430,7 @@
       </p:sp>
       <p:sp>
         <p:nvSpPr>
-          <p:cNvPr id="185" name="PlaceHolder 4"/>
+          <p:cNvPr id="183" name="PlaceHolder 4"/>
           <p:cNvSpPr>
             <a:spLocks noGrp="1"/>
           </p:cNvSpPr>
@@ -15355,7 +15441,7 @@
         <p:spPr>
           <a:xfrm>
             <a:off x="3355560" y="2503800"/>
-            <a:ext cx="2448360" cy="1285920"/>
+            <a:ext cx="2448360" cy="1462680"/>
           </a:xfrm>
           <a:prstGeom prst="rect">
             <a:avLst/>
@@ -15380,7 +15466,7 @@
               </a:tabLst>
             </a:pPr>
             <a:r>
-              <a:rPr lang="es" sz="1500" b="0" u="none" strike="noStrike">
+              <a:rPr lang="es" sz="1300" b="0" u="none" strike="noStrike">
                 <a:solidFill>
                   <a:schemeClr val="dk1"/>
                 </a:solidFill>
@@ -15389,9 +15475,77 @@
                 <a:latin typeface="Verdana"/>
                 <a:ea typeface="Verdana"/>
               </a:rPr>
-              <a:t>JavaScript y actualización del estado de la aplicación.</a:t>
-            </a:r>
-            <a:endParaRPr lang="en-US" sz="1500" b="0" u="none" strike="noStrike">
+              <a:t>CLI, router y formularios.</a:t>
+            </a:r>
+            <a:endParaRPr lang="en-US" sz="1300" b="0" u="none" strike="noStrike">
+              <a:solidFill>
+                <a:srgbClr val="000000"/>
+              </a:solidFill>
+              <a:effectLst/>
+              <a:uFillTx/>
+              <a:latin typeface="Arial"/>
+            </a:endParaRPr>
+          </a:p>
+          <a:p>
+            <a:pPr indent="0" algn="l">
+              <a:lnSpc>
+                <a:spcPct val="100000"/>
+              </a:lnSpc>
+              <a:spcAft>
+                <a:spcPts val="601"/>
+              </a:spcAft>
+              <a:buNone/>
+              <a:tabLst>
+                <a:tab pos="0" algn="l"/>
+              </a:tabLst>
+            </a:pPr>
+            <a:r>
+              <a:rPr lang="es" sz="1300" b="0" u="none" strike="noStrike">
+                <a:solidFill>
+                  <a:schemeClr val="dk1"/>
+                </a:solidFill>
+                <a:effectLst/>
+                <a:uFillTx/>
+                <a:latin typeface="Verdana"/>
+                <a:ea typeface="Verdana"/>
+              </a:rPr>
+              <a:t>Inyección de dependencias.</a:t>
+            </a:r>
+            <a:endParaRPr lang="en-US" sz="1300" b="0" u="none" strike="noStrike">
+              <a:solidFill>
+                <a:srgbClr val="000000"/>
+              </a:solidFill>
+              <a:effectLst/>
+              <a:uFillTx/>
+              <a:latin typeface="Arial"/>
+            </a:endParaRPr>
+          </a:p>
+          <a:p>
+            <a:pPr indent="0" algn="l">
+              <a:lnSpc>
+                <a:spcPct val="100000"/>
+              </a:lnSpc>
+              <a:spcAft>
+                <a:spcPts val="601"/>
+              </a:spcAft>
+              <a:buNone/>
+              <a:tabLst>
+                <a:tab pos="0" algn="l"/>
+              </a:tabLst>
+            </a:pPr>
+            <a:r>
+              <a:rPr lang="es" sz="1300" b="0" u="none" strike="noStrike">
+                <a:solidFill>
+                  <a:schemeClr val="dk1"/>
+                </a:solidFill>
+                <a:effectLst/>
+                <a:uFillTx/>
+                <a:latin typeface="Verdana"/>
+                <a:ea typeface="Verdana"/>
+              </a:rPr>
+              <a:t>Convenciones integradas.</a:t>
+            </a:r>
+            <a:endParaRPr lang="en-US" sz="1300" b="0" u="none" strike="noStrike">
               <a:solidFill>
                 <a:srgbClr val="000000"/>
               </a:solidFill>
@@ -15404,7 +15558,7 @@
       </p:sp>
       <p:sp>
         <p:nvSpPr>
-          <p:cNvPr id="186" name="PlaceHolder 5"/>
+          <p:cNvPr id="184" name="PlaceHolder 5"/>
           <p:cNvSpPr>
             <a:spLocks noGrp="1"/>
           </p:cNvSpPr>
@@ -15449,7 +15603,7 @@
                 <a:latin typeface="Verdana"/>
                 <a:ea typeface="Verdana"/>
               </a:rPr>
-              <a:t>PRESENTACIÓN</a:t>
+              <a:t>SVELTE</a:t>
             </a:r>
             <a:endParaRPr lang="en-US" sz="1600" b="0" u="none" strike="noStrike">
               <a:solidFill>
@@ -15464,7 +15618,7 @@
       </p:sp>
       <p:sp>
         <p:nvSpPr>
-          <p:cNvPr id="187" name="PlaceHolder 6"/>
+          <p:cNvPr id="185" name="PlaceHolder 6"/>
           <p:cNvSpPr>
             <a:spLocks noGrp="1"/>
           </p:cNvSpPr>
@@ -15475,7 +15629,7 @@
         <p:spPr>
           <a:xfrm>
             <a:off x="6119640" y="2503800"/>
-            <a:ext cx="2448360" cy="1285920"/>
+            <a:ext cx="2448360" cy="1462680"/>
           </a:xfrm>
           <a:prstGeom prst="rect">
             <a:avLst/>
@@ -15500,7 +15654,7 @@
               </a:tabLst>
             </a:pPr>
             <a:r>
-              <a:rPr lang="es" sz="1500" b="0" u="none" strike="noStrike">
+              <a:rPr lang="es" sz="1300" b="0" u="none" strike="noStrike">
                 <a:solidFill>
                   <a:schemeClr val="dk1"/>
                 </a:solidFill>
@@ -15509,9 +15663,77 @@
                 <a:latin typeface="Verdana"/>
                 <a:ea typeface="Verdana"/>
               </a:rPr>
-              <a:t>Trabajo restante hasta el siguiente pintado del navegador.</a:t>
-            </a:r>
-            <a:endParaRPr lang="en-US" sz="1500" b="0" u="none" strike="noStrike">
+              <a:t>Componentes compilados.</a:t>
+            </a:r>
+            <a:endParaRPr lang="en-US" sz="1300" b="0" u="none" strike="noStrike">
+              <a:solidFill>
+                <a:srgbClr val="000000"/>
+              </a:solidFill>
+              <a:effectLst/>
+              <a:uFillTx/>
+              <a:latin typeface="Arial"/>
+            </a:endParaRPr>
+          </a:p>
+          <a:p>
+            <a:pPr indent="0" algn="l">
+              <a:lnSpc>
+                <a:spcPct val="100000"/>
+              </a:lnSpc>
+              <a:spcAft>
+                <a:spcPts val="601"/>
+              </a:spcAft>
+              <a:buNone/>
+              <a:tabLst>
+                <a:tab pos="0" algn="l"/>
+              </a:tabLst>
+            </a:pPr>
+            <a:r>
+              <a:rPr lang="es" sz="1300" b="0" u="none" strike="noStrike">
+                <a:solidFill>
+                  <a:schemeClr val="dk1"/>
+                </a:solidFill>
+                <a:effectLst/>
+                <a:uFillTx/>
+                <a:latin typeface="Verdana"/>
+                <a:ea typeface="Verdana"/>
+              </a:rPr>
+              <a:t>SvelteKit añade routing y SSR.</a:t>
+            </a:r>
+            <a:endParaRPr lang="en-US" sz="1300" b="0" u="none" strike="noStrike">
+              <a:solidFill>
+                <a:srgbClr val="000000"/>
+              </a:solidFill>
+              <a:effectLst/>
+              <a:uFillTx/>
+              <a:latin typeface="Arial"/>
+            </a:endParaRPr>
+          </a:p>
+          <a:p>
+            <a:pPr indent="0" algn="l">
+              <a:lnSpc>
+                <a:spcPct val="100000"/>
+              </a:lnSpc>
+              <a:spcAft>
+                <a:spcPts val="601"/>
+              </a:spcAft>
+              <a:buNone/>
+              <a:tabLst>
+                <a:tab pos="0" algn="l"/>
+              </a:tabLst>
+            </a:pPr>
+            <a:r>
+              <a:rPr lang="es" sz="1300" b="0" u="none" strike="noStrike">
+                <a:solidFill>
+                  <a:schemeClr val="dk1"/>
+                </a:solidFill>
+                <a:effectLst/>
+                <a:uFillTx/>
+                <a:latin typeface="Verdana"/>
+                <a:ea typeface="Verdana"/>
+              </a:rPr>
+              <a:t>Vite integra el desarrollo.</a:t>
+            </a:r>
+            <a:endParaRPr lang="en-US" sz="1300" b="0" u="none" strike="noStrike">
               <a:solidFill>
                 <a:srgbClr val="000000"/>
               </a:solidFill>
@@ -15524,7 +15746,7 @@
       </p:sp>
       <p:sp>
         <p:nvSpPr>
-          <p:cNvPr id="188" name="PlaceHolder 7"/>
+          <p:cNvPr id="186" name="PlaceHolder 7"/>
           <p:cNvSpPr>
             <a:spLocks noGrp="1"/>
           </p:cNvSpPr>
@@ -15569,7 +15791,7 @@
                 <a:latin typeface="Verdana"/>
                 <a:ea typeface="Verdana"/>
               </a:rPr>
-              <a:t>F12 → Performance: respuesta de la interfaz</a:t>
+              <a:t>Herramientas y organización del proyecto</a:t>
             </a:r>
             <a:endParaRPr lang="en-US" sz="2200" b="0" u="none" strike="noStrike">
               <a:solidFill>
@@ -15584,7 +15806,7 @@
       </p:sp>
       <p:sp>
         <p:nvSpPr>
-          <p:cNvPr id="189" name="TextBox 280"/>
+          <p:cNvPr id="187" name="TextBox 280"/>
           <p:cNvSpPr/>
           <p:nvPr/>
         </p:nvSpPr>
@@ -15616,6 +15838,9 @@
               <a:lnSpc>
                 <a:spcPct val="100000"/>
               </a:lnSpc>
+              <a:spcAft>
+                <a:spcPts val="601"/>
+              </a:spcAft>
             </a:pPr>
             <a:r>
               <a:rPr lang="en-US" sz="1200" b="0" u="none" strike="noStrike">
@@ -15627,7 +15852,7 @@
                 <a:latin typeface="Verdana"/>
                 <a:ea typeface="Arial"/>
               </a:rPr>
-              <a:t>INP resume la sesión. Para cada prueba, selecciona su clic en la pista «Interactions».</a:t>
+              <a:t>El framework no determina por sí solo la arquitectura: también influyen las herramientas elegidas.</a:t>
             </a:r>
             <a:endParaRPr lang="en-US" sz="1200" b="0" u="none" strike="noStrike">
               <a:solidFill>
@@ -15672,7 +15897,7 @@
       </p:grpSpPr>
       <p:sp>
         <p:nvSpPr>
-          <p:cNvPr id="190" name="PlaceHolder 1"/>
+          <p:cNvPr id="188" name="PlaceHolder 1"/>
           <p:cNvSpPr>
             <a:spLocks noGrp="1"/>
           </p:cNvSpPr>
@@ -15708,7 +15933,7 @@
               </a:tabLst>
             </a:pPr>
             <a:r>
-              <a:rPr lang="es" sz="2200" b="1" u="none" strike="noStrike">
+              <a:rPr lang="es" sz="2300" b="1" u="none" strike="noStrike">
                 <a:solidFill>
                   <a:schemeClr val="dk1"/>
                 </a:solidFill>
@@ -15717,9 +15942,9 @@
                 <a:latin typeface="Verdana"/>
                 <a:ea typeface="Verdana"/>
               </a:rPr>
-              <a:t>Funcionamiento y resultados de rendimiento</a:t>
-            </a:r>
-            <a:endParaRPr lang="en-US" sz="2200" b="0" u="none" strike="noStrike">
+              <a:t>¿Cuál conviene elegir?</a:t>
+            </a:r>
+            <a:endParaRPr lang="en-US" sz="2300" b="0" u="none" strike="noStrike">
               <a:solidFill>
                 <a:srgbClr val="000000"/>
               </a:solidFill>
@@ -15732,7 +15957,7 @@
       </p:sp>
       <p:sp>
         <p:nvSpPr>
-          <p:cNvPr id="191" name="PlaceHolder 2"/>
+          <p:cNvPr id="189" name="PlaceHolder 2"/>
           <p:cNvSpPr>
             <a:spLocks noGrp="1"/>
           </p:cNvSpPr>
@@ -15777,7 +16002,7 @@
                 <a:latin typeface="Verdana"/>
                 <a:ea typeface="Verdana"/>
               </a:rPr>
-              <a:t>VERIFICADO</a:t>
+              <a:t>SEGÚN EL PROYECTO</a:t>
             </a:r>
             <a:endParaRPr lang="en-US" sz="1700" b="0" u="none" strike="noStrike">
               <a:solidFill>
@@ -15792,7 +16017,7 @@
       </p:sp>
       <p:sp>
         <p:nvSpPr>
-          <p:cNvPr id="192" name="PlaceHolder 3"/>
+          <p:cNvPr id="190" name="PlaceHolder 3"/>
           <p:cNvSpPr>
             <a:spLocks noGrp="1"/>
           </p:cNvSpPr>
@@ -15803,7 +16028,7 @@
         <p:spPr>
           <a:xfrm>
             <a:off x="673200" y="2743560"/>
-            <a:ext cx="3251520" cy="1285920"/>
+            <a:ext cx="3251520" cy="1737000"/>
           </a:xfrm>
           <a:prstGeom prst="rect">
             <a:avLst/>
@@ -15828,7 +16053,7 @@
               </a:tabLst>
             </a:pPr>
             <a:r>
-              <a:rPr lang="es" sz="1500" b="0" u="none" strike="noStrike">
+              <a:rPr lang="es" sz="1300" b="0" u="none" strike="noStrike">
                 <a:solidFill>
                   <a:schemeClr val="dk1"/>
                 </a:solidFill>
@@ -15837,9 +16062,9 @@
                 <a:latin typeface="Verdana"/>
                 <a:ea typeface="Verdana"/>
               </a:rPr>
-              <a:t>Las cuatro versiones compilan.</a:t>
-            </a:r>
-            <a:endParaRPr lang="en-US" sz="1500" b="0" u="none" strike="noStrike">
+              <a:t>React: flexibilidad y ecosistema amplio.</a:t>
+            </a:r>
+            <a:endParaRPr lang="en-US" sz="1300" b="0" u="none" strike="noStrike">
               <a:solidFill>
                 <a:srgbClr val="000000"/>
               </a:solidFill>
@@ -15853,13 +16078,16 @@
               <a:lnSpc>
                 <a:spcPct val="100000"/>
               </a:lnSpc>
+              <a:spcAft>
+                <a:spcPts val="601"/>
+              </a:spcAft>
               <a:buNone/>
               <a:tabLst>
                 <a:tab pos="0" algn="l"/>
               </a:tabLst>
             </a:pPr>
             <a:r>
-              <a:rPr lang="es" sz="1500" b="0" u="none" strike="noStrike">
+              <a:rPr lang="es" sz="1300" b="0" u="none" strike="noStrike">
                 <a:solidFill>
                   <a:schemeClr val="dk1"/>
                 </a:solidFill>
@@ -15868,9 +16096,9 @@
                 <a:latin typeface="Verdana"/>
                 <a:ea typeface="Verdana"/>
               </a:rPr>
-              <a:t>Búsqueda y formularios funcionan.</a:t>
-            </a:r>
-            <a:endParaRPr lang="en-US" sz="1500" b="0" u="none" strike="noStrike">
+              <a:t>Vue: adopción gradual y templates.</a:t>
+            </a:r>
+            <a:endParaRPr lang="en-US" sz="1300" b="0" u="none" strike="noStrike">
               <a:solidFill>
                 <a:srgbClr val="000000"/>
               </a:solidFill>
@@ -15884,13 +16112,16 @@
               <a:lnSpc>
                 <a:spcPct val="100000"/>
               </a:lnSpc>
+              <a:spcAft>
+                <a:spcPts val="601"/>
+              </a:spcAft>
               <a:buNone/>
               <a:tabLst>
                 <a:tab pos="0" algn="l"/>
               </a:tabLst>
             </a:pPr>
             <a:r>
-              <a:rPr lang="es" sz="1500" b="0" u="none" strike="noStrike">
+              <a:rPr lang="es" sz="1300" b="0" u="none" strike="noStrike">
                 <a:solidFill>
                   <a:schemeClr val="dk1"/>
                 </a:solidFill>
@@ -15899,9 +16130,43 @@
                 <a:latin typeface="Verdana"/>
                 <a:ea typeface="Verdana"/>
               </a:rPr>
-              <a:t>Limpiar y reinsertar 5.000 registros funciona.</a:t>
-            </a:r>
-            <a:endParaRPr lang="en-US" sz="1500" b="0" u="none" strike="noStrike">
+              <a:t>Angular: herramientas y convenciones.</a:t>
+            </a:r>
+            <a:endParaRPr lang="en-US" sz="1300" b="0" u="none" strike="noStrike">
+              <a:solidFill>
+                <a:srgbClr val="000000"/>
+              </a:solidFill>
+              <a:effectLst/>
+              <a:uFillTx/>
+              <a:latin typeface="Arial"/>
+            </a:endParaRPr>
+          </a:p>
+          <a:p>
+            <a:pPr indent="0" algn="l">
+              <a:lnSpc>
+                <a:spcPct val="100000"/>
+              </a:lnSpc>
+              <a:spcAft>
+                <a:spcPts val="601"/>
+              </a:spcAft>
+              <a:buNone/>
+              <a:tabLst>
+                <a:tab pos="0" algn="l"/>
+              </a:tabLst>
+            </a:pPr>
+            <a:r>
+              <a:rPr lang="es" sz="1300" b="0" u="none" strike="noStrike">
+                <a:solidFill>
+                  <a:schemeClr val="dk1"/>
+                </a:solidFill>
+                <a:effectLst/>
+                <a:uFillTx/>
+                <a:latin typeface="Verdana"/>
+                <a:ea typeface="Verdana"/>
+              </a:rPr>
+              <a:t>Svelte: enfoque de compilación.</a:t>
+            </a:r>
+            <a:endParaRPr lang="en-US" sz="1300" b="0" u="none" strike="noStrike">
               <a:solidFill>
                 <a:srgbClr val="000000"/>
               </a:solidFill>
@@ -15914,7 +16179,7 @@
       </p:sp>
       <p:sp>
         <p:nvSpPr>
-          <p:cNvPr id="193" name="PlaceHolder 4"/>
+          <p:cNvPr id="191" name="PlaceHolder 4"/>
           <p:cNvSpPr>
             <a:spLocks noGrp="1"/>
           </p:cNvSpPr>
@@ -15950,7 +16215,7 @@
               </a:tabLst>
             </a:pPr>
             <a:r>
-              <a:rPr lang="es" sz="1700" b="1" u="none" strike="noStrike">
+              <a:rPr lang="es" sz="1600" b="1" u="none" strike="noStrike">
                 <a:solidFill>
                   <a:srgbClr val="FF3A00"/>
                 </a:solidFill>
@@ -15959,9 +16224,9 @@
                 <a:latin typeface="Verdana"/>
                 <a:ea typeface="Verdana"/>
               </a:rPr>
-              <a:t>POR MEDIR</a:t>
-            </a:r>
-            <a:endParaRPr lang="en-US" sz="1700" b="0" u="none" strike="noStrike">
+              <a:t>SIN UN GANADOR UNIVERSAL</a:t>
+            </a:r>
+            <a:endParaRPr lang="en-US" sz="1600" b="0" u="none" strike="noStrike">
               <a:solidFill>
                 <a:srgbClr val="000000"/>
               </a:solidFill>
@@ -15974,7 +16239,7 @@
       </p:sp>
       <p:sp>
         <p:nvSpPr>
-          <p:cNvPr id="194" name="PlaceHolder 5"/>
+          <p:cNvPr id="192" name="PlaceHolder 5"/>
           <p:cNvSpPr>
             <a:spLocks noGrp="1"/>
           </p:cNvSpPr>
@@ -15985,7 +16250,7 @@
         <p:spPr>
           <a:xfrm>
             <a:off x="4785480" y="2743560"/>
-            <a:ext cx="3251520" cy="1285920"/>
+            <a:ext cx="3251520" cy="1737000"/>
           </a:xfrm>
           <a:prstGeom prst="rect">
             <a:avLst/>
@@ -16010,7 +16275,7 @@
               </a:tabLst>
             </a:pPr>
             <a:r>
-              <a:rPr lang="es" sz="1500" b="0" u="none" strike="noStrike">
+              <a:rPr lang="es" sz="1300" b="0" u="none" strike="noStrike">
                 <a:solidFill>
                   <a:schemeClr val="dk1"/>
                 </a:solidFill>
@@ -16019,9 +16284,9 @@
                 <a:latin typeface="Verdana"/>
                 <a:ea typeface="Verdana"/>
               </a:rPr>
-              <a:t>Latencia por escenario en producción.</a:t>
-            </a:r>
-            <a:endParaRPr lang="en-US" sz="1500" b="0" u="none" strike="noStrike">
+              <a:t>Evaluar experiencia del equipo.</a:t>
+            </a:r>
+            <a:endParaRPr lang="en-US" sz="1300" b="0" u="none" strike="noStrike">
               <a:solidFill>
                 <a:srgbClr val="000000"/>
               </a:solidFill>
@@ -16035,13 +16300,16 @@
               <a:lnSpc>
                 <a:spcPct val="100000"/>
               </a:lnSpc>
+              <a:spcAft>
+                <a:spcPts val="601"/>
+              </a:spcAft>
               <a:buNone/>
               <a:tabLst>
                 <a:tab pos="0" algn="l"/>
               </a:tabLst>
             </a:pPr>
             <a:r>
-              <a:rPr lang="es" sz="1500" b="0" u="none" strike="noStrike">
+              <a:rPr lang="es" sz="1300" b="0" u="none" strike="noStrike">
                 <a:solidFill>
                   <a:schemeClr val="dk1"/>
                 </a:solidFill>
@@ -16050,9 +16318,9 @@
                 <a:latin typeface="Verdana"/>
                 <a:ea typeface="Verdana"/>
               </a:rPr>
-              <a:t>Todas las filas frente a paginación.</a:t>
-            </a:r>
-            <a:endParaRPr lang="en-US" sz="1500" b="0" u="none" strike="noStrike">
+              <a:t>Integraciones y mantenimiento.</a:t>
+            </a:r>
+            <a:endParaRPr lang="en-US" sz="1300" b="0" u="none" strike="noStrike">
               <a:solidFill>
                 <a:srgbClr val="000000"/>
               </a:solidFill>
@@ -16066,13 +16334,16 @@
               <a:lnSpc>
                 <a:spcPct val="100000"/>
               </a:lnSpc>
+              <a:spcAft>
+                <a:spcPts val="601"/>
+              </a:spcAft>
               <a:buNone/>
               <a:tabLst>
                 <a:tab pos="0" algn="l"/>
               </a:tabLst>
             </a:pPr>
             <a:r>
-              <a:rPr lang="es" sz="1500" b="0" u="none" strike="noStrike">
+              <a:rPr lang="es" sz="1300" b="0" u="none" strike="noStrike">
                 <a:solidFill>
                   <a:schemeClr val="dk1"/>
                 </a:solidFill>
@@ -16081,97 +16352,43 @@
                 <a:latin typeface="Verdana"/>
                 <a:ea typeface="Verdana"/>
               </a:rPr>
-              <a:t>Sin un ganador hasta tener resultados.</a:t>
-            </a:r>
-            <a:endParaRPr lang="en-US" sz="1500" b="0" u="none" strike="noStrike">
-              <a:solidFill>
-                <a:srgbClr val="000000"/>
-              </a:solidFill>
-              <a:effectLst/>
-              <a:uFillTx/>
-              <a:latin typeface="Arial"/>
-            </a:endParaRPr>
-          </a:p>
-        </p:txBody>
-      </p:sp>
-      <p:sp>
-        <p:nvSpPr>
-          <p:cNvPr id="195" name="Google Shape;216;p28"/>
-          <p:cNvSpPr/>
-          <p:nvPr/>
-        </p:nvSpPr>
-        <p:spPr>
-          <a:xfrm>
-            <a:off x="768240" y="3946680"/>
-            <a:ext cx="165960" cy="37080"/>
-          </a:xfrm>
-          <a:prstGeom prst="rect">
-            <a:avLst/>
-          </a:prstGeom>
-          <a:solidFill>
-            <a:srgbClr val="FF3A00"/>
-          </a:solidFill>
-          <a:ln w="0">
-            <a:noFill/>
-          </a:ln>
-        </p:spPr>
-        <p:style>
-          <a:lnRef idx="0"/>
-          <a:fillRef idx="0"/>
-          <a:effectRef idx="0"/>
-          <a:fontRef idx="minor"/>
-        </p:style>
-        <p:txBody>
-          <a:bodyPr lIns="83160" tIns="18720" rIns="83160" bIns="18720" anchor="ctr">
-            <a:noAutofit/>
-          </a:bodyPr>
-          <a:p>
-            <a:pPr/>
-            <a:endParaRPr lang="en-US" sz="1400" b="0" u="none" strike="noStrike">
-              <a:solidFill>
-                <a:srgbClr val="000000"/>
-              </a:solidFill>
-              <a:effectLst/>
-              <a:uFillTx/>
-              <a:latin typeface="Arial"/>
-            </a:endParaRPr>
-          </a:p>
-        </p:txBody>
-      </p:sp>
-      <p:sp>
-        <p:nvSpPr>
-          <p:cNvPr id="196" name="Google Shape;216;p28"/>
-          <p:cNvSpPr/>
-          <p:nvPr/>
-        </p:nvSpPr>
-        <p:spPr>
-          <a:xfrm>
-            <a:off x="4880160" y="3946680"/>
-            <a:ext cx="165960" cy="37080"/>
-          </a:xfrm>
-          <a:prstGeom prst="rect">
-            <a:avLst/>
-          </a:prstGeom>
-          <a:solidFill>
-            <a:srgbClr val="FF3A00"/>
-          </a:solidFill>
-          <a:ln w="0">
-            <a:noFill/>
-          </a:ln>
-        </p:spPr>
-        <p:style>
-          <a:lnRef idx="0"/>
-          <a:fillRef idx="0"/>
-          <a:effectRef idx="0"/>
-          <a:fontRef idx="minor"/>
-        </p:style>
-        <p:txBody>
-          <a:bodyPr lIns="83160" tIns="18720" rIns="83160" bIns="18720" anchor="ctr">
-            <a:noAutofit/>
-          </a:bodyPr>
-          <a:p>
-            <a:pPr/>
-            <a:endParaRPr lang="en-US" sz="1400" b="0" u="none" strike="noStrike">
+              <a:t>Complejidad de la aplicación.</a:t>
+            </a:r>
+            <a:endParaRPr lang="en-US" sz="1300" b="0" u="none" strike="noStrike">
+              <a:solidFill>
+                <a:srgbClr val="000000"/>
+              </a:solidFill>
+              <a:effectLst/>
+              <a:uFillTx/>
+              <a:latin typeface="Arial"/>
+            </a:endParaRPr>
+          </a:p>
+          <a:p>
+            <a:pPr indent="0" algn="l">
+              <a:lnSpc>
+                <a:spcPct val="100000"/>
+              </a:lnSpc>
+              <a:spcAft>
+                <a:spcPts val="601"/>
+              </a:spcAft>
+              <a:buNone/>
+              <a:tabLst>
+                <a:tab pos="0" algn="l"/>
+              </a:tabLst>
+            </a:pPr>
+            <a:r>
+              <a:rPr lang="es" sz="1300" b="0" u="none" strike="noStrike">
+                <a:solidFill>
+                  <a:schemeClr val="dk1"/>
+                </a:solidFill>
+                <a:effectLst/>
+                <a:uFillTx/>
+                <a:latin typeface="Verdana"/>
+                <a:ea typeface="Verdana"/>
+              </a:rPr>
+              <a:t>Medir rendimiento en casos equivalentes.</a:t>
+            </a:r>
+            <a:endParaRPr lang="en-US" sz="1300" b="0" u="none" strike="noStrike">
               <a:solidFill>
                 <a:srgbClr val="000000"/>
               </a:solidFill>
@@ -16214,7 +16431,7 @@
       </p:grpSpPr>
       <p:sp>
         <p:nvSpPr>
-          <p:cNvPr id="197" name="PlaceHolder 1"/>
+          <p:cNvPr id="193" name="PlaceHolder 1"/>
           <p:cNvSpPr>
             <a:spLocks noGrp="1"/>
           </p:cNvSpPr>
@@ -16250,7 +16467,7 @@
               </a:tabLst>
             </a:pPr>
             <a:r>
-              <a:rPr lang="es" sz="4800" b="1" u="none" strike="noStrike">
+              <a:rPr lang="es" sz="4400" b="1" u="none" strike="noStrike">
                 <a:solidFill>
                   <a:schemeClr val="lt1"/>
                 </a:solidFill>
@@ -16259,9 +16476,9 @@
                 <a:latin typeface="Verdana"/>
                 <a:ea typeface="Verdana"/>
               </a:rPr>
-              <a:t>Demostración</a:t>
-            </a:r>
-            <a:endParaRPr lang="en-US" sz="4800" b="1" u="none" strike="noStrike">
+              <a:t>Del concepto</a:t>
+            </a:r>
+            <a:endParaRPr lang="en-US" sz="4400" b="1" u="none" strike="noStrike">
               <a:solidFill>
                 <a:schemeClr val="lt1"/>
               </a:solidFill>
@@ -16275,13 +16492,16 @@
               <a:lnSpc>
                 <a:spcPts val="7999"/>
               </a:lnSpc>
+              <a:spcAft>
+                <a:spcPts val="601"/>
+              </a:spcAft>
               <a:buNone/>
               <a:tabLst>
                 <a:tab pos="0" algn="l"/>
               </a:tabLst>
             </a:pPr>
             <a:r>
-              <a:rPr lang="es" sz="4800" b="1" u="none" strike="noStrike">
+              <a:rPr lang="es" sz="4400" b="1" u="none" strike="noStrike">
                 <a:solidFill>
                   <a:schemeClr val="lt1"/>
                 </a:solidFill>
@@ -16290,9 +16510,9 @@
                 <a:latin typeface="Verdana"/>
                 <a:ea typeface="Verdana"/>
               </a:rPr>
-              <a:t>en vivo</a:t>
-            </a:r>
-            <a:endParaRPr lang="en-US" sz="4800" b="1" u="none" strike="noStrike">
+              <a:t>a la práctica</a:t>
+            </a:r>
+            <a:endParaRPr lang="en-US" sz="4400" b="1" u="none" strike="noStrike">
               <a:solidFill>
                 <a:schemeClr val="lt1"/>
               </a:solidFill>
@@ -16305,7 +16525,7 @@
       </p:sp>
       <p:sp>
         <p:nvSpPr>
-          <p:cNvPr id="198" name="PlaceHolder 2"/>
+          <p:cNvPr id="194" name="PlaceHolder 2"/>
           <p:cNvSpPr>
             <a:spLocks noGrp="1"/>
           </p:cNvSpPr>
@@ -16335,13 +16555,16 @@
               <a:lnSpc>
                 <a:spcPct val="100000"/>
               </a:lnSpc>
+              <a:spcAft>
+                <a:spcPts val="601"/>
+              </a:spcAft>
               <a:buNone/>
               <a:tabLst>
                 <a:tab pos="0" algn="l"/>
               </a:tabLst>
             </a:pPr>
             <a:r>
-              <a:rPr lang="es-PE" sz="1600" b="0" u="none" strike="noStrike">
+              <a:rPr lang="es-PE" sz="1500" b="0" u="none" strike="noStrike">
                 <a:solidFill>
                   <a:srgbClr val="FFFFFF"/>
                 </a:solidFill>
@@ -16350,9 +16573,9 @@
                 <a:latin typeface="Verdana"/>
                 <a:ea typeface="Verdana"/>
               </a:rPr>
-              <a:t>Todas las filas → Limpiar → Grabar en F12 → Insertar 5.000</a:t>
-            </a:r>
-            <a:endParaRPr lang="en-US" sz="1600" b="0" u="none" strike="noStrike">
+              <a:t>InventoryPro: el mismo inventario en React, Vue, Angular y Svelte.</a:t>
+            </a:r>
+            <a:endParaRPr lang="en-US" sz="1500" b="0" u="none" strike="noStrike">
               <a:solidFill>
                 <a:srgbClr val="FFFFFF"/>
               </a:solidFill>
@@ -16366,13 +16589,16 @@
               <a:lnSpc>
                 <a:spcPct val="100000"/>
               </a:lnSpc>
+              <a:spcAft>
+                <a:spcPts val="601"/>
+              </a:spcAft>
               <a:buNone/>
               <a:tabLst>
                 <a:tab pos="0" algn="l"/>
               </a:tabLst>
             </a:pPr>
             <a:r>
-              <a:rPr lang="es-PE" sz="1600" b="0" u="none" strike="noStrike">
+              <a:rPr lang="es-PE" sz="1500" b="0" u="none" strike="noStrike">
                 <a:solidFill>
                   <a:srgbClr val="FFFFFF"/>
                 </a:solidFill>
@@ -16381,9 +16607,9 @@
                 <a:latin typeface="Verdana"/>
                 <a:ea typeface="Verdana"/>
               </a:rPr>
-              <a:t>Repetir en React, Vue, Angular y Svelte.</a:t>
-            </a:r>
-            <a:endParaRPr lang="en-US" sz="1600" b="0" u="none" strike="noStrike">
+              <a:t>Demostración: buscar, gestionar productos y comparar 5.000 filas con F12.</a:t>
+            </a:r>
+            <a:endParaRPr lang="en-US" sz="1500" b="0" u="none" strike="noStrike">
               <a:solidFill>
                 <a:srgbClr val="FFFFFF"/>
               </a:solidFill>

</xml_diff>